<commit_message>
deck: drop the under-development URL, add entity timeline on slide 3
Co-authored-by: arena-agent <297053741+arena-agent@users.noreply.github.com>
</commit_message>
<xml_diff>
--- a/deck/KD-PAY-Airwallex-Partnership.pptx
+++ b/deck/KD-PAY-Airwallex-Partnership.pptx
@@ -19747,7 +19747,7 @@
                 </a:solidFill>
                 <a:latin typeface="Arial"/>
               </a:rPr>
-              <a:t>Since 2022 through KD Solution IT (kdsolutionit.com). KD PAY LLC is the new contracting and processing entity, registered October 2026.</a:t>
+              <a:t>Since 2022 through our operating company, KD Solution IT. KD PAY LLC is the new contracting and processing entity, registered October 2026.</a:t>
             </a:r>
           </a:p>
           <a:p>
@@ -19846,14 +19846,439 @@
                 </a:solidFill>
                 <a:latin typeface="Arial"/>
               </a:rPr>
-              <a:t>A small engineering team that ships. We build on a written specification: double-entry ledger, row-level tenant isolation, hash-chained audit trail — not a white-label reseller.</a:t>
-            </a:r>
-          </a:p>
-        </p:txBody>
-      </p:sp>
-      <p:sp>
-        <p:nvSpPr>
-          <p:cNvPr id="6" name="Rounded Rectangle 5"/>
+              <a:t>A small team that ships, against a written specification: double-entry ledger, row-level tenant isolation, hash-chained audit trail — not a white-label reseller.</a:t>
+            </a:r>
+          </a:p>
+        </p:txBody>
+      </p:sp>
+      <p:cxnSp>
+        <p:nvCxnSpPr>
+          <p:cNvPr id="6" name="Connector 5"/>
+          <p:cNvCxnSpPr/>
+          <p:nvPr/>
+        </p:nvCxnSpPr>
+        <p:spPr>
+          <a:xfrm>
+            <a:off x="658368" y="4910328"/>
+            <a:ext cx="5715000" cy="0"/>
+          </a:xfrm>
+          <a:prstGeom prst="line">
+            <a:avLst/>
+          </a:prstGeom>
+          <a:ln w="10160">
+            <a:solidFill>
+              <a:srgbClr val="DFE6EE"/>
+            </a:solidFill>
+          </a:ln>
+        </p:spPr>
+        <p:style>
+          <a:lnRef idx="2">
+            <a:schemeClr val="accent1"/>
+          </a:lnRef>
+          <a:fillRef idx="0">
+            <a:schemeClr val="accent1"/>
+          </a:fillRef>
+          <a:effectRef idx="1">
+            <a:schemeClr val="accent1"/>
+          </a:effectRef>
+          <a:fontRef idx="minor">
+            <a:schemeClr val="tx1"/>
+          </a:fontRef>
+        </p:style>
+      </p:cxnSp>
+      <p:sp>
+        <p:nvSpPr>
+          <p:cNvPr id="7" name="Rounded Rectangle 6"/>
+          <p:cNvSpPr/>
+          <p:nvPr/>
+        </p:nvSpPr>
+        <p:spPr>
+          <a:xfrm>
+            <a:off x="658368" y="4869180"/>
+            <a:ext cx="100584" cy="100584"/>
+          </a:xfrm>
+          <a:prstGeom prst="roundRect">
+            <a:avLst>
+              <a:gd name="adj" fmla="val 50000"/>
+            </a:avLst>
+          </a:prstGeom>
+          <a:solidFill>
+            <a:srgbClr val="00B589"/>
+          </a:solidFill>
+          <a:ln>
+            <a:noFill/>
+          </a:ln>
+          <a:effectLst/>
+        </p:spPr>
+        <p:style>
+          <a:lnRef idx="1">
+            <a:schemeClr val="accent1"/>
+          </a:lnRef>
+          <a:fillRef idx="3">
+            <a:schemeClr val="accent1"/>
+          </a:fillRef>
+          <a:effectRef idx="2">
+            <a:schemeClr val="accent1"/>
+          </a:effectRef>
+          <a:fontRef idx="minor">
+            <a:schemeClr val="lt1"/>
+          </a:fontRef>
+        </p:style>
+        <p:txBody>
+          <a:bodyPr rtlCol="0" anchor="ctr" wrap="square"/>
+          <a:lstStyle/>
+          <a:p>
+            <a:pPr algn="ctr"/>
+          </a:p>
+        </p:txBody>
+      </p:sp>
+      <p:sp>
+        <p:nvSpPr>
+          <p:cNvPr id="8" name="TextBox 7"/>
+          <p:cNvSpPr txBox="1"/>
+          <p:nvPr/>
+        </p:nvSpPr>
+        <p:spPr>
+          <a:xfrm>
+            <a:off x="658368" y="5056632"/>
+            <a:ext cx="1630680" cy="201168"/>
+          </a:xfrm>
+          <a:prstGeom prst="rect">
+            <a:avLst/>
+          </a:prstGeom>
+          <a:noFill/>
+        </p:spPr>
+        <p:txBody>
+          <a:bodyPr wrap="square" lIns="0" tIns="0" rIns="0" bIns="0" anchor="t">
+            <a:spAutoFit/>
+          </a:bodyPr>
+          <a:lstStyle/>
+          <a:p>
+            <a:pPr algn="l">
+              <a:lnSpc>
+                <a:spcPct val="112000"/>
+              </a:lnSpc>
+              <a:spcAft>
+                <a:spcPts val="0"/>
+              </a:spcAft>
+            </a:pPr>
+            <a:r>
+              <a:rPr sz="850" b="1" i="0" spc="110">
+                <a:solidFill>
+                  <a:srgbClr val="008A69"/>
+                </a:solidFill>
+                <a:latin typeface="Arial"/>
+              </a:rPr>
+              <a:t>2022</a:t>
+            </a:r>
+          </a:p>
+        </p:txBody>
+      </p:sp>
+      <p:sp>
+        <p:nvSpPr>
+          <p:cNvPr id="9" name="TextBox 8"/>
+          <p:cNvSpPr txBox="1"/>
+          <p:nvPr/>
+        </p:nvSpPr>
+        <p:spPr>
+          <a:xfrm>
+            <a:off x="658368" y="5257800"/>
+            <a:ext cx="1630680" cy="384048"/>
+          </a:xfrm>
+          <a:prstGeom prst="rect">
+            <a:avLst/>
+          </a:prstGeom>
+          <a:noFill/>
+        </p:spPr>
+        <p:txBody>
+          <a:bodyPr wrap="square" lIns="0" tIns="0" rIns="0" bIns="0" anchor="t">
+            <a:spAutoFit/>
+          </a:bodyPr>
+          <a:lstStyle/>
+          <a:p>
+            <a:pPr algn="l">
+              <a:lnSpc>
+                <a:spcPct val="118000"/>
+              </a:lnSpc>
+              <a:spcAft>
+                <a:spcPts val="0"/>
+              </a:spcAft>
+            </a:pPr>
+            <a:r>
+              <a:rPr sz="930" b="0" i="0">
+                <a:solidFill>
+                  <a:srgbClr val="5B6E82"/>
+                </a:solidFill>
+                <a:latin typeface="Arial"/>
+              </a:rPr>
+              <a:t>Trading starts under KD Solution IT</a:t>
+            </a:r>
+          </a:p>
+        </p:txBody>
+      </p:sp>
+      <p:sp>
+        <p:nvSpPr>
+          <p:cNvPr id="10" name="Rounded Rectangle 9"/>
+          <p:cNvSpPr/>
+          <p:nvPr/>
+        </p:nvSpPr>
+        <p:spPr>
+          <a:xfrm>
+            <a:off x="2563368" y="4869180"/>
+            <a:ext cx="100584" cy="100584"/>
+          </a:xfrm>
+          <a:prstGeom prst="roundRect">
+            <a:avLst>
+              <a:gd name="adj" fmla="val 50000"/>
+            </a:avLst>
+          </a:prstGeom>
+          <a:solidFill>
+            <a:srgbClr val="00B589"/>
+          </a:solidFill>
+          <a:ln>
+            <a:noFill/>
+          </a:ln>
+          <a:effectLst/>
+        </p:spPr>
+        <p:style>
+          <a:lnRef idx="1">
+            <a:schemeClr val="accent1"/>
+          </a:lnRef>
+          <a:fillRef idx="3">
+            <a:schemeClr val="accent1"/>
+          </a:fillRef>
+          <a:effectRef idx="2">
+            <a:schemeClr val="accent1"/>
+          </a:effectRef>
+          <a:fontRef idx="minor">
+            <a:schemeClr val="lt1"/>
+          </a:fontRef>
+        </p:style>
+        <p:txBody>
+          <a:bodyPr rtlCol="0" anchor="ctr" wrap="square"/>
+          <a:lstStyle/>
+          <a:p>
+            <a:pPr algn="ctr"/>
+          </a:p>
+        </p:txBody>
+      </p:sp>
+      <p:sp>
+        <p:nvSpPr>
+          <p:cNvPr id="11" name="TextBox 10"/>
+          <p:cNvSpPr txBox="1"/>
+          <p:nvPr/>
+        </p:nvSpPr>
+        <p:spPr>
+          <a:xfrm>
+            <a:off x="2563368" y="5056632"/>
+            <a:ext cx="1630680" cy="201168"/>
+          </a:xfrm>
+          <a:prstGeom prst="rect">
+            <a:avLst/>
+          </a:prstGeom>
+          <a:noFill/>
+        </p:spPr>
+        <p:txBody>
+          <a:bodyPr wrap="square" lIns="0" tIns="0" rIns="0" bIns="0" anchor="t">
+            <a:spAutoFit/>
+          </a:bodyPr>
+          <a:lstStyle/>
+          <a:p>
+            <a:pPr algn="l">
+              <a:lnSpc>
+                <a:spcPct val="112000"/>
+              </a:lnSpc>
+              <a:spcAft>
+                <a:spcPts val="0"/>
+              </a:spcAft>
+            </a:pPr>
+            <a:r>
+              <a:rPr sz="850" b="1" i="0" spc="110">
+                <a:solidFill>
+                  <a:srgbClr val="008A69"/>
+                </a:solidFill>
+                <a:latin typeface="Arial"/>
+              </a:rPr>
+              <a:t>OCT 2026</a:t>
+            </a:r>
+          </a:p>
+        </p:txBody>
+      </p:sp>
+      <p:sp>
+        <p:nvSpPr>
+          <p:cNvPr id="12" name="TextBox 11"/>
+          <p:cNvSpPr txBox="1"/>
+          <p:nvPr/>
+        </p:nvSpPr>
+        <p:spPr>
+          <a:xfrm>
+            <a:off x="2563368" y="5257800"/>
+            <a:ext cx="1630680" cy="384048"/>
+          </a:xfrm>
+          <a:prstGeom prst="rect">
+            <a:avLst/>
+          </a:prstGeom>
+          <a:noFill/>
+        </p:spPr>
+        <p:txBody>
+          <a:bodyPr wrap="square" lIns="0" tIns="0" rIns="0" bIns="0" anchor="t">
+            <a:spAutoFit/>
+          </a:bodyPr>
+          <a:lstStyle/>
+          <a:p>
+            <a:pPr algn="l">
+              <a:lnSpc>
+                <a:spcPct val="118000"/>
+              </a:lnSpc>
+              <a:spcAft>
+                <a:spcPts val="0"/>
+              </a:spcAft>
+            </a:pPr>
+            <a:r>
+              <a:rPr sz="930" b="0" i="0">
+                <a:solidFill>
+                  <a:srgbClr val="5B6E82"/>
+                </a:solidFill>
+                <a:latin typeface="Arial"/>
+              </a:rPr>
+              <a:t>KD PAY LLC registered</a:t>
+            </a:r>
+          </a:p>
+        </p:txBody>
+      </p:sp>
+      <p:sp>
+        <p:nvSpPr>
+          <p:cNvPr id="13" name="Rounded Rectangle 12"/>
+          <p:cNvSpPr/>
+          <p:nvPr/>
+        </p:nvSpPr>
+        <p:spPr>
+          <a:xfrm>
+            <a:off x="4468368" y="4869180"/>
+            <a:ext cx="100584" cy="100584"/>
+          </a:xfrm>
+          <a:prstGeom prst="roundRect">
+            <a:avLst>
+              <a:gd name="adj" fmla="val 50000"/>
+            </a:avLst>
+          </a:prstGeom>
+          <a:solidFill>
+            <a:srgbClr val="00B589"/>
+          </a:solidFill>
+          <a:ln>
+            <a:noFill/>
+          </a:ln>
+          <a:effectLst/>
+        </p:spPr>
+        <p:style>
+          <a:lnRef idx="1">
+            <a:schemeClr val="accent1"/>
+          </a:lnRef>
+          <a:fillRef idx="3">
+            <a:schemeClr val="accent1"/>
+          </a:fillRef>
+          <a:effectRef idx="2">
+            <a:schemeClr val="accent1"/>
+          </a:effectRef>
+          <a:fontRef idx="minor">
+            <a:schemeClr val="lt1"/>
+          </a:fontRef>
+        </p:style>
+        <p:txBody>
+          <a:bodyPr rtlCol="0" anchor="ctr" wrap="square"/>
+          <a:lstStyle/>
+          <a:p>
+            <a:pPr algn="ctr"/>
+          </a:p>
+        </p:txBody>
+      </p:sp>
+      <p:sp>
+        <p:nvSpPr>
+          <p:cNvPr id="14" name="TextBox 13"/>
+          <p:cNvSpPr txBox="1"/>
+          <p:nvPr/>
+        </p:nvSpPr>
+        <p:spPr>
+          <a:xfrm>
+            <a:off x="4468368" y="5056632"/>
+            <a:ext cx="1630680" cy="201168"/>
+          </a:xfrm>
+          <a:prstGeom prst="rect">
+            <a:avLst/>
+          </a:prstGeom>
+          <a:noFill/>
+        </p:spPr>
+        <p:txBody>
+          <a:bodyPr wrap="square" lIns="0" tIns="0" rIns="0" bIns="0" anchor="t">
+            <a:spAutoFit/>
+          </a:bodyPr>
+          <a:lstStyle/>
+          <a:p>
+            <a:pPr algn="l">
+              <a:lnSpc>
+                <a:spcPct val="112000"/>
+              </a:lnSpc>
+              <a:spcAft>
+                <a:spcPts val="0"/>
+              </a:spcAft>
+            </a:pPr>
+            <a:r>
+              <a:rPr sz="850" b="1" i="0" spc="110">
+                <a:solidFill>
+                  <a:srgbClr val="008A69"/>
+                </a:solidFill>
+                <a:latin typeface="Arial"/>
+              </a:rPr>
+              <a:t>NEXT</a:t>
+            </a:r>
+          </a:p>
+        </p:txBody>
+      </p:sp>
+      <p:sp>
+        <p:nvSpPr>
+          <p:cNvPr id="15" name="TextBox 14"/>
+          <p:cNvSpPr txBox="1"/>
+          <p:nvPr/>
+        </p:nvSpPr>
+        <p:spPr>
+          <a:xfrm>
+            <a:off x="4468368" y="5257800"/>
+            <a:ext cx="1630680" cy="384048"/>
+          </a:xfrm>
+          <a:prstGeom prst="rect">
+            <a:avLst/>
+          </a:prstGeom>
+          <a:noFill/>
+        </p:spPr>
+        <p:txBody>
+          <a:bodyPr wrap="square" lIns="0" tIns="0" rIns="0" bIns="0" anchor="t">
+            <a:spAutoFit/>
+          </a:bodyPr>
+          <a:lstStyle/>
+          <a:p>
+            <a:pPr algn="l">
+              <a:lnSpc>
+                <a:spcPct val="118000"/>
+              </a:lnSpc>
+              <a:spcAft>
+                <a:spcPts val="0"/>
+              </a:spcAft>
+            </a:pPr>
+            <a:r>
+              <a:rPr sz="930" b="0" i="0">
+                <a:solidFill>
+                  <a:srgbClr val="5B6E82"/>
+                </a:solidFill>
+                <a:latin typeface="Arial"/>
+              </a:rPr>
+              <a:t>Platform launch on Airwallex</a:t>
+            </a:r>
+          </a:p>
+        </p:txBody>
+      </p:sp>
+      <p:sp>
+        <p:nvSpPr>
+          <p:cNvPr id="16" name="Rounded Rectangle 15"/>
           <p:cNvSpPr/>
           <p:nvPr/>
         </p:nvSpPr>
@@ -19899,7 +20324,7 @@
       </p:sp>
       <p:sp>
         <p:nvSpPr>
-          <p:cNvPr id="7" name="TextBox 6"/>
+          <p:cNvPr id="17" name="TextBox 16"/>
           <p:cNvSpPr txBox="1"/>
           <p:nvPr/>
         </p:nvSpPr>
@@ -19941,7 +20366,7 @@
       </p:sp>
       <p:sp>
         <p:nvSpPr>
-          <p:cNvPr id="8" name="TextBox 7"/>
+          <p:cNvPr id="18" name="TextBox 17"/>
           <p:cNvSpPr txBox="1"/>
           <p:nvPr/>
         </p:nvSpPr>
@@ -19983,7 +20408,7 @@
       </p:sp>
       <p:sp>
         <p:nvSpPr>
-          <p:cNvPr id="9" name="TextBox 8"/>
+          <p:cNvPr id="19" name="TextBox 18"/>
           <p:cNvSpPr txBox="1"/>
           <p:nvPr/>
         </p:nvSpPr>
@@ -20025,7 +20450,7 @@
       </p:sp>
       <p:sp>
         <p:nvSpPr>
-          <p:cNvPr id="10" name="TextBox 9"/>
+          <p:cNvPr id="20" name="TextBox 19"/>
           <p:cNvSpPr txBox="1"/>
           <p:nvPr/>
         </p:nvSpPr>
@@ -20067,7 +20492,7 @@
       </p:sp>
       <p:sp>
         <p:nvSpPr>
-          <p:cNvPr id="11" name="TextBox 10"/>
+          <p:cNvPr id="21" name="TextBox 20"/>
           <p:cNvSpPr txBox="1"/>
           <p:nvPr/>
         </p:nvSpPr>
@@ -20109,7 +20534,7 @@
       </p:sp>
       <p:sp>
         <p:nvSpPr>
-          <p:cNvPr id="12" name="TextBox 11"/>
+          <p:cNvPr id="22" name="TextBox 21"/>
           <p:cNvSpPr txBox="1"/>
           <p:nvPr/>
         </p:nvSpPr>
@@ -20144,14 +20569,14 @@
                 </a:solidFill>
                 <a:latin typeface="Arial"/>
               </a:rPr>
-              <a:t>WEBSITE</a:t>
-            </a:r>
-          </a:p>
-        </p:txBody>
-      </p:sp>
-      <p:sp>
-        <p:nvSpPr>
-          <p:cNvPr id="13" name="TextBox 12"/>
+              <a:t>PRODUCT STAGE</a:t>
+            </a:r>
+          </a:p>
+        </p:txBody>
+      </p:sp>
+      <p:sp>
+        <p:nvSpPr>
+          <p:cNvPr id="23" name="TextBox 22"/>
           <p:cNvSpPr txBox="1"/>
           <p:nvPr/>
         </p:nvSpPr>
@@ -20186,14 +20611,14 @@
                 </a:solidFill>
                 <a:latin typeface="Arial"/>
               </a:rPr>
-              <a:t>kdsolutionit.com</a:t>
-            </a:r>
-          </a:p>
-        </p:txBody>
-      </p:sp>
-      <p:sp>
-        <p:nvSpPr>
-          <p:cNvPr id="14" name="TextBox 13"/>
+              <a:t>Pre-launch, design-partner stage</a:t>
+            </a:r>
+          </a:p>
+        </p:txBody>
+      </p:sp>
+      <p:sp>
+        <p:nvSpPr>
+          <p:cNvPr id="24" name="TextBox 23"/>
           <p:cNvSpPr txBox="1"/>
           <p:nvPr/>
         </p:nvSpPr>
@@ -20235,7 +20660,7 @@
       </p:sp>
       <p:sp>
         <p:nvSpPr>
-          <p:cNvPr id="15" name="TextBox 14"/>
+          <p:cNvPr id="25" name="TextBox 24"/>
           <p:cNvSpPr txBox="1"/>
           <p:nvPr/>
         </p:nvSpPr>
@@ -20277,7 +20702,7 @@
       </p:sp>
       <p:sp>
         <p:nvSpPr>
-          <p:cNvPr id="16" name="TextBox 15"/>
+          <p:cNvPr id="26" name="TextBox 25"/>
           <p:cNvSpPr txBox="1"/>
           <p:nvPr/>
         </p:nvSpPr>
@@ -20319,7 +20744,7 @@
       </p:sp>
       <p:sp>
         <p:nvSpPr>
-          <p:cNvPr id="17" name="TextBox 16"/>
+          <p:cNvPr id="27" name="TextBox 26"/>
           <p:cNvSpPr txBox="1"/>
           <p:nvPr/>
         </p:nvSpPr>
@@ -20361,7 +20786,7 @@
       </p:sp>
       <p:sp>
         <p:nvSpPr>
-          <p:cNvPr id="18" name="TextBox 17"/>
+          <p:cNvPr id="28" name="TextBox 27"/>
           <p:cNvSpPr txBox="1"/>
           <p:nvPr/>
         </p:nvSpPr>
@@ -20403,7 +20828,7 @@
       </p:sp>
       <p:sp>
         <p:nvSpPr>
-          <p:cNvPr id="19" name="TextBox 18"/>
+          <p:cNvPr id="29" name="TextBox 28"/>
           <p:cNvSpPr txBox="1"/>
           <p:nvPr/>
         </p:nvSpPr>
@@ -20445,7 +20870,7 @@
       </p:sp>
       <p:sp>
         <p:nvSpPr>
-          <p:cNvPr id="20" name="TextBox 19"/>
+          <p:cNvPr id="30" name="TextBox 29"/>
           <p:cNvSpPr txBox="1"/>
           <p:nvPr/>
         </p:nvSpPr>
@@ -20487,7 +20912,7 @@
       </p:sp>
       <p:sp>
         <p:nvSpPr>
-          <p:cNvPr id="21" name="TextBox 20"/>
+          <p:cNvPr id="31" name="TextBox 30"/>
           <p:cNvSpPr txBox="1"/>
           <p:nvPr/>
         </p:nvSpPr>
@@ -20529,7 +20954,7 @@
       </p:sp>
       <p:cxnSp>
         <p:nvCxnSpPr>
-          <p:cNvPr id="22" name="Connector 21"/>
+          <p:cNvPr id="32" name="Connector 31"/>
           <p:cNvCxnSpPr/>
           <p:nvPr/>
         </p:nvCxnSpPr>
@@ -20564,7 +20989,7 @@
       </p:cxnSp>
       <p:sp>
         <p:nvSpPr>
-          <p:cNvPr id="23" name="TextBox 22"/>
+          <p:cNvPr id="33" name="TextBox 32"/>
           <p:cNvSpPr txBox="1"/>
           <p:nvPr/>
         </p:nvSpPr>
@@ -20606,7 +21031,7 @@
       </p:sp>
       <p:sp>
         <p:nvSpPr>
-          <p:cNvPr id="24" name="TextBox 23"/>
+          <p:cNvPr id="34" name="TextBox 33"/>
           <p:cNvSpPr txBox="1"/>
           <p:nvPr/>
         </p:nvSpPr>

</xml_diff>